<commit_message>
docs: add Workshop 2 architecture diagram
</commit_message>
<xml_diff>
--- a/docs/workshops/presentations/flo-bank-workshop-2.pptx
+++ b/docs/workshops/presentations/flo-bank-workshop-2.pptx
@@ -1836,7 +1836,7 @@
           </a:p>
           <a:p>
             <a:r>
-              <a:t>Optional live review first obtains the case and calls the model through Gate 1. Show boundary response cards rather than relying on the diagram. Independent observer snapshot reads have a separate identity and do not prove the denied payment reached Core Banking.</a:t>
+              <a:t>Read the diagram in two stages. The Governance Studio backend first reads the case through MCP and Gate 3. For live review, it sends minimal case context through Gate 1 to the hosted model and validates at most one returned payment proposal. Recorded replay supplies a fixed proposal without inference. Both payment paths enter Gate 2, where the MCP adapter validates signed identity and arguments and queries OPA. An allowed payment traverses Gate 3 API-key authentication and Core Banking's signed-identity, approval and ledger rules. Approval-required requests can persist a pending proposal with no debit. PostgreSQL holds banking records; exported telemetry is inspected in Jaeger. APISIX implements all three logical gateway routes. Gate 1 enforces inference budgets and output limits; this lab has no dedicated gateway prompt-injection filter. Model instructions treat case text as untrusted. Denied payment calls stop at Gate 2; independent observer reads do not prove that payment reached Core Banking.</a:t>
             </a:r>
           </a:p>
           <a:p/>
@@ -18323,7 +18323,7 @@
               </a:defRPr>
             </a:pPr>
             <a:r>
-              <a:t>Follow the proposal to its stopping point</a:t>
+              <a:t>Workshop 2 architecture: proposal to execution</a:t>
             </a:r>
           </a:p>
         </p:txBody>
@@ -18336,8 +18336,8 @@
         </p:nvSpPr>
         <p:spPr>
           <a:xfrm>
-            <a:off x="533400" y="2451100"/>
-            <a:ext cx="2571750" cy="3073400"/>
+            <a:off x="533400" y="2006600"/>
+            <a:ext cx="2349500" cy="1041400"/>
           </a:xfrm>
           <a:prstGeom prst="roundRect">
             <a:avLst>
@@ -18381,31 +18381,31 @@
         </p:nvSpPr>
         <p:spPr>
           <a:xfrm>
-            <a:off x="723900" y="2654300"/>
-            <a:ext cx="2190750" cy="482600"/>
-          </a:xfrm>
-          <a:prstGeom prst="rect">
-            <a:avLst/>
-          </a:prstGeom>
-          <a:noFill/>
-        </p:spPr>
-        <p:txBody>
-          <a:bodyPr wrap="none" lIns="0" rIns="0" tIns="0" bIns="0" anchor="t">
-            <a:spAutoFit/>
-          </a:bodyPr>
-          <a:lstStyle/>
-          <a:p>
-            <a:pPr>
-              <a:lnSpc>
-                <a:spcPts val="2750"/>
-              </a:lnSpc>
-              <a:spcBef>
-                <a:spcPts val="0"/>
-              </a:spcBef>
-              <a:spcAft>
-                <a:spcPts val="0"/>
-              </a:spcAft>
-              <a:defRPr sz="2200" b="1">
+            <a:off x="660400" y="2120900"/>
+            <a:ext cx="2095500" cy="317500"/>
+          </a:xfrm>
+          <a:prstGeom prst="rect">
+            <a:avLst/>
+          </a:prstGeom>
+          <a:noFill/>
+        </p:spPr>
+        <p:txBody>
+          <a:bodyPr wrap="none" lIns="0" rIns="0" tIns="0" bIns="0" anchor="t">
+            <a:spAutoFit/>
+          </a:bodyPr>
+          <a:lstStyle/>
+          <a:p>
+            <a:pPr>
+              <a:lnSpc>
+                <a:spcPts val="1687"/>
+              </a:lnSpc>
+              <a:spcBef>
+                <a:spcPts val="0"/>
+              </a:spcBef>
+              <a:spcAft>
+                <a:spcPts val="0"/>
+              </a:spcAft>
+              <a:defRPr sz="1350" b="1">
                 <a:solidFill>
                   <a:srgbClr val="007F79"/>
                 </a:solidFill>
@@ -18413,7 +18413,7 @@
               </a:defRPr>
             </a:pPr>
             <a:r>
-              <a:t>01</a:t>
+              <a:t>Flo / Studio backend</a:t>
             </a:r>
           </a:p>
         </p:txBody>
@@ -18426,31 +18426,31 @@
         </p:nvSpPr>
         <p:spPr>
           <a:xfrm>
-            <a:off x="723900" y="3289300"/>
-            <a:ext cx="2190750" cy="825500"/>
-          </a:xfrm>
-          <a:prstGeom prst="rect">
-            <a:avLst/>
-          </a:prstGeom>
-          <a:noFill/>
-        </p:spPr>
-        <p:txBody>
-          <a:bodyPr wrap="none" lIns="0" rIns="0" tIns="0" bIns="0" anchor="t">
-            <a:spAutoFit/>
-          </a:bodyPr>
-          <a:lstStyle/>
-          <a:p>
-            <a:pPr>
-              <a:lnSpc>
-                <a:spcPts val="2250"/>
-              </a:lnSpc>
-              <a:spcBef>
-                <a:spcPts val="0"/>
-              </a:spcBef>
-              <a:spcAft>
-                <a:spcPts val="0"/>
-              </a:spcAft>
-              <a:defRPr sz="1800" b="1">
+            <a:off x="660400" y="2463800"/>
+            <a:ext cx="2095500" cy="533400"/>
+          </a:xfrm>
+          <a:prstGeom prst="rect">
+            <a:avLst/>
+          </a:prstGeom>
+          <a:noFill/>
+        </p:spPr>
+        <p:txBody>
+          <a:bodyPr wrap="none" lIns="0" rIns="0" tIns="0" bIns="0" anchor="t">
+            <a:spAutoFit/>
+          </a:bodyPr>
+          <a:lstStyle/>
+          <a:p>
+            <a:pPr>
+              <a:lnSpc>
+                <a:spcPts val="1380"/>
+              </a:lnSpc>
+              <a:spcBef>
+                <a:spcPts val="0"/>
+              </a:spcBef>
+              <a:spcAft>
+                <a:spcPts val="0"/>
+              </a:spcAft>
+              <a:defRPr sz="1200" b="0">
                 <a:solidFill>
                   <a:srgbClr val="163640"/>
                 </a:solidFill>
@@ -18458,7 +18458,29 @@
               </a:defRPr>
             </a:pPr>
             <a:r>
-              <a:t>Proposal</a:t>
+              <a:t>Read case via MCP first;</a:t>
+            </a:r>
+          </a:p>
+          <a:p>
+            <a:pPr>
+              <a:lnSpc>
+                <a:spcPts val="1380"/>
+              </a:lnSpc>
+              <a:spcBef>
+                <a:spcPts val="0"/>
+              </a:spcBef>
+              <a:spcAft>
+                <a:spcPts val="0"/>
+              </a:spcAft>
+              <a:defRPr sz="1200" b="0">
+                <a:solidFill>
+                  <a:srgbClr val="163640"/>
+                </a:solidFill>
+                <a:latin typeface="DejaVu Sans"/>
+              </a:defRPr>
+            </a:pPr>
+            <a:r>
+              <a:t>validate model proposal</a:t>
             </a:r>
           </a:p>
         </p:txBody>
@@ -18471,98 +18493,31 @@
         </p:nvSpPr>
         <p:spPr>
           <a:xfrm>
-            <a:off x="723900" y="4140200"/>
-            <a:ext cx="2190750" cy="1257300"/>
-          </a:xfrm>
-          <a:prstGeom prst="rect">
-            <a:avLst/>
-          </a:prstGeom>
-          <a:noFill/>
-        </p:spPr>
-        <p:txBody>
-          <a:bodyPr wrap="none" lIns="0" rIns="0" tIns="0" bIns="0" anchor="t">
-            <a:spAutoFit/>
-          </a:bodyPr>
-          <a:lstStyle/>
-          <a:p>
-            <a:pPr>
-              <a:lnSpc>
-                <a:spcPts val="2125"/>
-              </a:lnSpc>
-              <a:spcBef>
-                <a:spcPts val="0"/>
-              </a:spcBef>
-              <a:spcAft>
-                <a:spcPts val="0"/>
-              </a:spcAft>
-              <a:defRPr sz="1700" b="0">
-                <a:solidFill>
-                  <a:srgbClr val="163640"/>
-                </a:solidFill>
-                <a:latin typeface="DejaVu Sans"/>
-              </a:defRPr>
-            </a:pPr>
-            <a:r>
-              <a:t>Recorded or live</a:t>
-            </a:r>
-          </a:p>
-          <a:p>
-            <a:pPr>
-              <a:lnSpc>
-                <a:spcPts val="2125"/>
-              </a:lnSpc>
-              <a:spcBef>
-                <a:spcPts val="0"/>
-              </a:spcBef>
-              <a:spcAft>
-                <a:spcPts val="0"/>
-              </a:spcAft>
-              <a:defRPr sz="1700" b="0">
-                <a:solidFill>
-                  <a:srgbClr val="163640"/>
-                </a:solidFill>
-                <a:latin typeface="DejaVu Sans"/>
-              </a:defRPr>
-            </a:pPr>
-            <a:r>
-              <a:t>source</a:t>
-            </a:r>
-          </a:p>
-        </p:txBody>
-      </p:sp>
-      <p:sp>
-        <p:nvSpPr>
-          <p:cNvPr id="10" name="TextBox 9"/>
-          <p:cNvSpPr txBox="1"/>
-          <p:nvPr/>
-        </p:nvSpPr>
-        <p:spPr>
-          <a:xfrm>
-            <a:off x="3143250" y="3556000"/>
-            <a:ext cx="254000" cy="330200"/>
-          </a:xfrm>
-          <a:prstGeom prst="rect">
-            <a:avLst/>
-          </a:prstGeom>
-          <a:noFill/>
-        </p:spPr>
-        <p:txBody>
-          <a:bodyPr wrap="none" lIns="0" rIns="0" tIns="0" bIns="0" anchor="t">
-            <a:spAutoFit/>
-          </a:bodyPr>
-          <a:lstStyle/>
-          <a:p>
-            <a:pPr>
-              <a:lnSpc>
-                <a:spcPts val="2187"/>
-              </a:lnSpc>
-              <a:spcBef>
-                <a:spcPts val="0"/>
-              </a:spcBef>
-              <a:spcAft>
-                <a:spcPts val="0"/>
-              </a:spcAft>
-              <a:defRPr sz="1750" b="0">
+            <a:off x="2971800" y="2286000"/>
+            <a:ext cx="381000" cy="355600"/>
+          </a:xfrm>
+          <a:prstGeom prst="rect">
+            <a:avLst/>
+          </a:prstGeom>
+          <a:noFill/>
+        </p:spPr>
+        <p:txBody>
+          <a:bodyPr wrap="none" lIns="0" rIns="0" tIns="0" bIns="0" anchor="t">
+            <a:spAutoFit/>
+          </a:bodyPr>
+          <a:lstStyle/>
+          <a:p>
+            <a:pPr>
+              <a:lnSpc>
+                <a:spcPts val="2375"/>
+              </a:lnSpc>
+              <a:spcBef>
+                <a:spcPts val="0"/>
+              </a:spcBef>
+              <a:spcAft>
+                <a:spcPts val="0"/>
+              </a:spcAft>
+              <a:defRPr sz="1900" b="0">
                 <a:solidFill>
                   <a:srgbClr val="007F79"/>
                 </a:solidFill>
@@ -18577,14 +18532,14 @@
       </p:sp>
       <p:sp>
         <p:nvSpPr>
-          <p:cNvPr id="11" name="Rounded Rectangle 10"/>
+          <p:cNvPr id="10" name="Rounded Rectangle 9"/>
           <p:cNvSpPr/>
           <p:nvPr/>
         </p:nvSpPr>
         <p:spPr>
           <a:xfrm>
-            <a:off x="3384550" y="2451100"/>
-            <a:ext cx="2571750" cy="3073400"/>
+            <a:off x="3390900" y="2006600"/>
+            <a:ext cx="2413000" cy="1041400"/>
           </a:xfrm>
           <a:prstGeom prst="roundRect">
             <a:avLst>
@@ -18622,37 +18577,149 @@
       </p:sp>
       <p:sp>
         <p:nvSpPr>
+          <p:cNvPr id="11" name="TextBox 10"/>
+          <p:cNvSpPr txBox="1"/>
+          <p:nvPr/>
+        </p:nvSpPr>
+        <p:spPr>
+          <a:xfrm>
+            <a:off x="3517900" y="2120900"/>
+            <a:ext cx="2159000" cy="317500"/>
+          </a:xfrm>
+          <a:prstGeom prst="rect">
+            <a:avLst/>
+          </a:prstGeom>
+          <a:noFill/>
+        </p:spPr>
+        <p:txBody>
+          <a:bodyPr wrap="none" lIns="0" rIns="0" tIns="0" bIns="0" anchor="t">
+            <a:spAutoFit/>
+          </a:bodyPr>
+          <a:lstStyle/>
+          <a:p>
+            <a:pPr>
+              <a:lnSpc>
+                <a:spcPts val="1750"/>
+              </a:lnSpc>
+              <a:spcBef>
+                <a:spcPts val="0"/>
+              </a:spcBef>
+              <a:spcAft>
+                <a:spcPts val="0"/>
+              </a:spcAft>
+              <a:defRPr sz="1400" b="1">
+                <a:solidFill>
+                  <a:srgbClr val="007F79"/>
+                </a:solidFill>
+                <a:latin typeface="DejaVu Sans"/>
+              </a:defRPr>
+            </a:pPr>
+            <a:r>
+              <a:t>Gate 1 / AI adapter</a:t>
+            </a:r>
+          </a:p>
+        </p:txBody>
+      </p:sp>
+      <p:sp>
+        <p:nvSpPr>
           <p:cNvPr id="12" name="TextBox 11"/>
           <p:cNvSpPr txBox="1"/>
           <p:nvPr/>
         </p:nvSpPr>
         <p:spPr>
           <a:xfrm>
-            <a:off x="3575050" y="2654300"/>
-            <a:ext cx="2190750" cy="482600"/>
-          </a:xfrm>
-          <a:prstGeom prst="rect">
-            <a:avLst/>
-          </a:prstGeom>
-          <a:noFill/>
-        </p:spPr>
-        <p:txBody>
-          <a:bodyPr wrap="none" lIns="0" rIns="0" tIns="0" bIns="0" anchor="t">
-            <a:spAutoFit/>
-          </a:bodyPr>
-          <a:lstStyle/>
-          <a:p>
-            <a:pPr>
-              <a:lnSpc>
-                <a:spcPts val="2750"/>
-              </a:lnSpc>
-              <a:spcBef>
-                <a:spcPts val="0"/>
-              </a:spcBef>
-              <a:spcAft>
-                <a:spcPts val="0"/>
-              </a:spcAft>
-              <a:defRPr sz="2200" b="1">
+            <a:off x="3517900" y="2463800"/>
+            <a:ext cx="2159000" cy="533400"/>
+          </a:xfrm>
+          <a:prstGeom prst="rect">
+            <a:avLst/>
+          </a:prstGeom>
+          <a:noFill/>
+        </p:spPr>
+        <p:txBody>
+          <a:bodyPr wrap="none" lIns="0" rIns="0" tIns="0" bIns="0" anchor="t">
+            <a:spAutoFit/>
+          </a:bodyPr>
+          <a:lstStyle/>
+          <a:p>
+            <a:pPr>
+              <a:lnSpc>
+                <a:spcPts val="1380"/>
+              </a:lnSpc>
+              <a:spcBef>
+                <a:spcPts val="0"/>
+              </a:spcBef>
+              <a:spcAft>
+                <a:spcPts val="0"/>
+              </a:spcAft>
+              <a:defRPr sz="1200" b="0">
+                <a:solidFill>
+                  <a:srgbClr val="163640"/>
+                </a:solidFill>
+                <a:latin typeface="DejaVu Sans"/>
+              </a:defRPr>
+            </a:pPr>
+            <a:r>
+              <a:t>Inference token budget</a:t>
+            </a:r>
+          </a:p>
+          <a:p>
+            <a:pPr>
+              <a:lnSpc>
+                <a:spcPts val="1380"/>
+              </a:lnSpc>
+              <a:spcBef>
+                <a:spcPts val="0"/>
+              </a:spcBef>
+              <a:spcAft>
+                <a:spcPts val="0"/>
+              </a:spcAft>
+              <a:defRPr sz="1200" b="0">
+                <a:solidFill>
+                  <a:srgbClr val="163640"/>
+                </a:solidFill>
+                <a:latin typeface="DejaVu Sans"/>
+              </a:defRPr>
+            </a:pPr>
+            <a:r>
+              <a:t>and output limits</a:t>
+            </a:r>
+          </a:p>
+        </p:txBody>
+      </p:sp>
+      <p:sp>
+        <p:nvSpPr>
+          <p:cNvPr id="13" name="TextBox 12"/>
+          <p:cNvSpPr txBox="1"/>
+          <p:nvPr/>
+        </p:nvSpPr>
+        <p:spPr>
+          <a:xfrm>
+            <a:off x="5905500" y="2286000"/>
+            <a:ext cx="381000" cy="355600"/>
+          </a:xfrm>
+          <a:prstGeom prst="rect">
+            <a:avLst/>
+          </a:prstGeom>
+          <a:noFill/>
+        </p:spPr>
+        <p:txBody>
+          <a:bodyPr wrap="none" lIns="0" rIns="0" tIns="0" bIns="0" anchor="t">
+            <a:spAutoFit/>
+          </a:bodyPr>
+          <a:lstStyle/>
+          <a:p>
+            <a:pPr>
+              <a:lnSpc>
+                <a:spcPts val="2375"/>
+              </a:lnSpc>
+              <a:spcBef>
+                <a:spcPts val="0"/>
+              </a:spcBef>
+              <a:spcAft>
+                <a:spcPts val="0"/>
+              </a:spcAft>
+              <a:defRPr sz="1900" b="0">
                 <a:solidFill>
                   <a:srgbClr val="007F79"/>
                 </a:solidFill>
@@ -18660,163 +18727,6 @@
               </a:defRPr>
             </a:pPr>
             <a:r>
-              <a:t>02</a:t>
-            </a:r>
-          </a:p>
-        </p:txBody>
-      </p:sp>
-      <p:sp>
-        <p:nvSpPr>
-          <p:cNvPr id="13" name="TextBox 12"/>
-          <p:cNvSpPr txBox="1"/>
-          <p:nvPr/>
-        </p:nvSpPr>
-        <p:spPr>
-          <a:xfrm>
-            <a:off x="3575050" y="3289300"/>
-            <a:ext cx="2190750" cy="825500"/>
-          </a:xfrm>
-          <a:prstGeom prst="rect">
-            <a:avLst/>
-          </a:prstGeom>
-          <a:noFill/>
-        </p:spPr>
-        <p:txBody>
-          <a:bodyPr wrap="none" lIns="0" rIns="0" tIns="0" bIns="0" anchor="t">
-            <a:spAutoFit/>
-          </a:bodyPr>
-          <a:lstStyle/>
-          <a:p>
-            <a:pPr>
-              <a:lnSpc>
-                <a:spcPts val="2250"/>
-              </a:lnSpc>
-              <a:spcBef>
-                <a:spcPts val="0"/>
-              </a:spcBef>
-              <a:spcAft>
-                <a:spcPts val="0"/>
-              </a:spcAft>
-              <a:defRPr sz="1800" b="1">
-                <a:solidFill>
-                  <a:srgbClr val="163640"/>
-                </a:solidFill>
-                <a:latin typeface="DejaVu Sans"/>
-              </a:defRPr>
-            </a:pPr>
-            <a:r>
-              <a:t>Gate 2</a:t>
-            </a:r>
-          </a:p>
-        </p:txBody>
-      </p:sp>
-      <p:sp>
-        <p:nvSpPr>
-          <p:cNvPr id="14" name="TextBox 13"/>
-          <p:cNvSpPr txBox="1"/>
-          <p:nvPr/>
-        </p:nvSpPr>
-        <p:spPr>
-          <a:xfrm>
-            <a:off x="3575050" y="4140200"/>
-            <a:ext cx="2190750" cy="1257300"/>
-          </a:xfrm>
-          <a:prstGeom prst="rect">
-            <a:avLst/>
-          </a:prstGeom>
-          <a:noFill/>
-        </p:spPr>
-        <p:txBody>
-          <a:bodyPr wrap="none" lIns="0" rIns="0" tIns="0" bIns="0" anchor="t">
-            <a:spAutoFit/>
-          </a:bodyPr>
-          <a:lstStyle/>
-          <a:p>
-            <a:pPr>
-              <a:lnSpc>
-                <a:spcPts val="2125"/>
-              </a:lnSpc>
-              <a:spcBef>
-                <a:spcPts val="0"/>
-              </a:spcBef>
-              <a:spcAft>
-                <a:spcPts val="0"/>
-              </a:spcAft>
-              <a:defRPr sz="1700" b="0">
-                <a:solidFill>
-                  <a:srgbClr val="163640"/>
-                </a:solidFill>
-                <a:latin typeface="DejaVu Sans"/>
-              </a:defRPr>
-            </a:pPr>
-            <a:r>
-              <a:t>Identity + actual</a:t>
-            </a:r>
-          </a:p>
-          <a:p>
-            <a:pPr>
-              <a:lnSpc>
-                <a:spcPts val="2125"/>
-              </a:lnSpc>
-              <a:spcBef>
-                <a:spcPts val="0"/>
-              </a:spcBef>
-              <a:spcAft>
-                <a:spcPts val="0"/>
-              </a:spcAft>
-              <a:defRPr sz="1700" b="0">
-                <a:solidFill>
-                  <a:srgbClr val="163640"/>
-                </a:solidFill>
-                <a:latin typeface="DejaVu Sans"/>
-              </a:defRPr>
-            </a:pPr>
-            <a:r>
-              <a:t>arguments</a:t>
-            </a:r>
-          </a:p>
-        </p:txBody>
-      </p:sp>
-      <p:sp>
-        <p:nvSpPr>
-          <p:cNvPr id="15" name="TextBox 14"/>
-          <p:cNvSpPr txBox="1"/>
-          <p:nvPr/>
-        </p:nvSpPr>
-        <p:spPr>
-          <a:xfrm>
-            <a:off x="5994400" y="3556000"/>
-            <a:ext cx="254000" cy="330200"/>
-          </a:xfrm>
-          <a:prstGeom prst="rect">
-            <a:avLst/>
-          </a:prstGeom>
-          <a:noFill/>
-        </p:spPr>
-        <p:txBody>
-          <a:bodyPr wrap="none" lIns="0" rIns="0" tIns="0" bIns="0" anchor="t">
-            <a:spAutoFit/>
-          </a:bodyPr>
-          <a:lstStyle/>
-          <a:p>
-            <a:pPr>
-              <a:lnSpc>
-                <a:spcPts val="2187"/>
-              </a:lnSpc>
-              <a:spcBef>
-                <a:spcPts val="0"/>
-              </a:spcBef>
-              <a:spcAft>
-                <a:spcPts val="0"/>
-              </a:spcAft>
-              <a:defRPr sz="1750" b="0">
-                <a:solidFill>
-                  <a:srgbClr val="007F79"/>
-                </a:solidFill>
-                <a:latin typeface="DejaVu Sans"/>
-              </a:defRPr>
-            </a:pPr>
-            <a:r>
               <a:t>→</a:t>
             </a:r>
           </a:p>
@@ -18824,14 +18734,14 @@
       </p:sp>
       <p:sp>
         <p:nvSpPr>
-          <p:cNvPr id="16" name="Rounded Rectangle 15"/>
+          <p:cNvPr id="14" name="Rounded Rectangle 13"/>
           <p:cNvSpPr/>
           <p:nvPr/>
         </p:nvSpPr>
         <p:spPr>
           <a:xfrm>
-            <a:off x="6235700" y="2451100"/>
-            <a:ext cx="2571750" cy="3073400"/>
+            <a:off x="6337300" y="2006600"/>
+            <a:ext cx="2349500" cy="1041400"/>
           </a:xfrm>
           <a:prstGeom prst="roundRect">
             <a:avLst>
@@ -18869,37 +18779,284 @@
       </p:sp>
       <p:sp>
         <p:nvSpPr>
+          <p:cNvPr id="15" name="TextBox 14"/>
+          <p:cNvSpPr txBox="1"/>
+          <p:nvPr/>
+        </p:nvSpPr>
+        <p:spPr>
+          <a:xfrm>
+            <a:off x="6464300" y="2120900"/>
+            <a:ext cx="2095500" cy="317500"/>
+          </a:xfrm>
+          <a:prstGeom prst="rect">
+            <a:avLst/>
+          </a:prstGeom>
+          <a:noFill/>
+        </p:spPr>
+        <p:txBody>
+          <a:bodyPr wrap="none" lIns="0" rIns="0" tIns="0" bIns="0" anchor="t">
+            <a:spAutoFit/>
+          </a:bodyPr>
+          <a:lstStyle/>
+          <a:p>
+            <a:pPr>
+              <a:lnSpc>
+                <a:spcPts val="1750"/>
+              </a:lnSpc>
+              <a:spcBef>
+                <a:spcPts val="0"/>
+              </a:spcBef>
+              <a:spcAft>
+                <a:spcPts val="0"/>
+              </a:spcAft>
+              <a:defRPr sz="1400" b="1">
+                <a:solidFill>
+                  <a:srgbClr val="007F79"/>
+                </a:solidFill>
+                <a:latin typeface="DejaVu Sans"/>
+              </a:defRPr>
+            </a:pPr>
+            <a:r>
+              <a:t>Hosted LLM</a:t>
+            </a:r>
+          </a:p>
+        </p:txBody>
+      </p:sp>
+      <p:sp>
+        <p:nvSpPr>
+          <p:cNvPr id="16" name="TextBox 15"/>
+          <p:cNvSpPr txBox="1"/>
+          <p:nvPr/>
+        </p:nvSpPr>
+        <p:spPr>
+          <a:xfrm>
+            <a:off x="6464300" y="2463800"/>
+            <a:ext cx="2095500" cy="533400"/>
+          </a:xfrm>
+          <a:prstGeom prst="rect">
+            <a:avLst/>
+          </a:prstGeom>
+          <a:noFill/>
+        </p:spPr>
+        <p:txBody>
+          <a:bodyPr wrap="none" lIns="0" rIns="0" tIns="0" bIns="0" anchor="t">
+            <a:spAutoFit/>
+          </a:bodyPr>
+          <a:lstStyle/>
+          <a:p>
+            <a:pPr>
+              <a:lnSpc>
+                <a:spcPts val="1380"/>
+              </a:lnSpc>
+              <a:spcBef>
+                <a:spcPts val="0"/>
+              </a:spcBef>
+              <a:spcAft>
+                <a:spcPts val="0"/>
+              </a:spcAft>
+              <a:defRPr sz="1200" b="0">
+                <a:solidFill>
+                  <a:srgbClr val="163640"/>
+                </a:solidFill>
+                <a:latin typeface="DejaVu Sans"/>
+              </a:defRPr>
+            </a:pPr>
+            <a:r>
+              <a:t>Live review: returns a</a:t>
+            </a:r>
+          </a:p>
+          <a:p>
+            <a:pPr>
+              <a:lnSpc>
+                <a:spcPts val="1380"/>
+              </a:lnSpc>
+              <a:spcBef>
+                <a:spcPts val="0"/>
+              </a:spcBef>
+              <a:spcAft>
+                <a:spcPts val="0"/>
+              </a:spcAft>
+              <a:defRPr sz="1200" b="0">
+                <a:solidFill>
+                  <a:srgbClr val="163640"/>
+                </a:solidFill>
+                <a:latin typeface="DejaVu Sans"/>
+              </a:defRPr>
+            </a:pPr>
+            <a:r>
+              <a:t>proposal or refusal</a:t>
+            </a:r>
+          </a:p>
+        </p:txBody>
+      </p:sp>
+      <p:sp>
+        <p:nvSpPr>
           <p:cNvPr id="17" name="TextBox 16"/>
           <p:cNvSpPr txBox="1"/>
           <p:nvPr/>
         </p:nvSpPr>
         <p:spPr>
           <a:xfrm>
-            <a:off x="6426200" y="2654300"/>
-            <a:ext cx="2190750" cy="482600"/>
-          </a:xfrm>
-          <a:prstGeom prst="rect">
-            <a:avLst/>
-          </a:prstGeom>
-          <a:noFill/>
-        </p:spPr>
-        <p:txBody>
-          <a:bodyPr wrap="none" lIns="0" rIns="0" tIns="0" bIns="0" anchor="t">
-            <a:spAutoFit/>
-          </a:bodyPr>
-          <a:lstStyle/>
-          <a:p>
-            <a:pPr>
-              <a:lnSpc>
-                <a:spcPts val="2750"/>
-              </a:lnSpc>
-              <a:spcBef>
-                <a:spcPts val="0"/>
-              </a:spcBef>
-              <a:spcAft>
-                <a:spcPts val="0"/>
-              </a:spcAft>
-              <a:defRPr sz="2200" b="1">
+            <a:off x="8877300" y="2133600"/>
+            <a:ext cx="2730500" cy="330200"/>
+          </a:xfrm>
+          <a:prstGeom prst="rect">
+            <a:avLst/>
+          </a:prstGeom>
+          <a:noFill/>
+        </p:spPr>
+        <p:txBody>
+          <a:bodyPr wrap="none" lIns="0" rIns="0" tIns="0" bIns="0" anchor="t">
+            <a:spAutoFit/>
+          </a:bodyPr>
+          <a:lstStyle/>
+          <a:p>
+            <a:pPr>
+              <a:lnSpc>
+                <a:spcPts val="1500"/>
+              </a:lnSpc>
+              <a:spcBef>
+                <a:spcPts val="0"/>
+              </a:spcBef>
+              <a:spcAft>
+                <a:spcPts val="0"/>
+              </a:spcAft>
+              <a:defRPr sz="1200" b="0">
+                <a:solidFill>
+                  <a:srgbClr val="536B73"/>
+                </a:solidFill>
+                <a:latin typeface="DejaVu Sans"/>
+              </a:defRPr>
+            </a:pPr>
+            <a:r>
+              <a:t>Proposal returns to Flo</a:t>
+            </a:r>
+          </a:p>
+        </p:txBody>
+      </p:sp>
+      <p:sp>
+        <p:nvSpPr>
+          <p:cNvPr id="18" name="TextBox 17"/>
+          <p:cNvSpPr txBox="1"/>
+          <p:nvPr/>
+        </p:nvSpPr>
+        <p:spPr>
+          <a:xfrm>
+            <a:off x="8877300" y="2527300"/>
+            <a:ext cx="2730500" cy="355600"/>
+          </a:xfrm>
+          <a:prstGeom prst="rect">
+            <a:avLst/>
+          </a:prstGeom>
+          <a:noFill/>
+        </p:spPr>
+        <p:txBody>
+          <a:bodyPr wrap="none" lIns="0" rIns="0" tIns="0" bIns="0" anchor="t">
+            <a:spAutoFit/>
+          </a:bodyPr>
+          <a:lstStyle/>
+          <a:p>
+            <a:pPr>
+              <a:lnSpc>
+                <a:spcPts val="1500"/>
+              </a:lnSpc>
+              <a:spcBef>
+                <a:spcPts val="0"/>
+              </a:spcBef>
+              <a:spcAft>
+                <a:spcPts val="0"/>
+              </a:spcAft>
+              <a:defRPr sz="1200" b="0">
+                <a:solidFill>
+                  <a:srgbClr val="536B73"/>
+                </a:solidFill>
+                <a:latin typeface="DejaVu Sans"/>
+              </a:defRPr>
+            </a:pPr>
+            <a:r>
+              <a:t>then enters MCP below ↓</a:t>
+            </a:r>
+          </a:p>
+        </p:txBody>
+      </p:sp>
+      <p:sp>
+        <p:nvSpPr>
+          <p:cNvPr id="19" name="Rounded Rectangle 18"/>
+          <p:cNvSpPr/>
+          <p:nvPr/>
+        </p:nvSpPr>
+        <p:spPr>
+          <a:xfrm>
+            <a:off x="533400" y="3429000"/>
+            <a:ext cx="2349500" cy="1104900"/>
+          </a:xfrm>
+          <a:prstGeom prst="roundRect">
+            <a:avLst>
+              <a:gd name="adj" fmla="val 6000"/>
+            </a:avLst>
+          </a:prstGeom>
+          <a:solidFill>
+            <a:srgbClr val="E0ECE6"/>
+          </a:solidFill>
+          <a:ln>
+            <a:noFill/>
+          </a:ln>
+        </p:spPr>
+        <p:style>
+          <a:lnRef idx="1">
+            <a:schemeClr val="accent1"/>
+          </a:lnRef>
+          <a:fillRef idx="3">
+            <a:schemeClr val="accent1"/>
+          </a:fillRef>
+          <a:effectRef idx="2">
+            <a:schemeClr val="accent1"/>
+          </a:effectRef>
+          <a:fontRef idx="minor">
+            <a:schemeClr val="lt1"/>
+          </a:fontRef>
+        </p:style>
+        <p:txBody>
+          <a:bodyPr rtlCol="0" anchor="ctr"/>
+          <a:lstStyle/>
+          <a:p>
+            <a:pPr algn="ctr"/>
+          </a:p>
+        </p:txBody>
+      </p:sp>
+      <p:sp>
+        <p:nvSpPr>
+          <p:cNvPr id="20" name="TextBox 19"/>
+          <p:cNvSpPr txBox="1"/>
+          <p:nvPr/>
+        </p:nvSpPr>
+        <p:spPr>
+          <a:xfrm>
+            <a:off x="660400" y="3543300"/>
+            <a:ext cx="2095500" cy="317500"/>
+          </a:xfrm>
+          <a:prstGeom prst="rect">
+            <a:avLst/>
+          </a:prstGeom>
+          <a:noFill/>
+        </p:spPr>
+        <p:txBody>
+          <a:bodyPr wrap="none" lIns="0" rIns="0" tIns="0" bIns="0" anchor="t">
+            <a:spAutoFit/>
+          </a:bodyPr>
+          <a:lstStyle/>
+          <a:p>
+            <a:pPr>
+              <a:lnSpc>
+                <a:spcPts val="1750"/>
+              </a:lnSpc>
+              <a:spcBef>
+                <a:spcPts val="0"/>
+              </a:spcBef>
+              <a:spcAft>
+                <a:spcPts val="0"/>
+              </a:spcAft>
+              <a:defRPr sz="1400" b="1">
                 <a:solidFill>
                   <a:srgbClr val="007F79"/>
                 </a:solidFill>
@@ -18907,44 +19064,44 @@
               </a:defRPr>
             </a:pPr>
             <a:r>
-              <a:t>03</a:t>
-            </a:r>
-          </a:p>
-        </p:txBody>
-      </p:sp>
-      <p:sp>
-        <p:nvSpPr>
-          <p:cNvPr id="18" name="TextBox 17"/>
-          <p:cNvSpPr txBox="1"/>
-          <p:nvPr/>
-        </p:nvSpPr>
-        <p:spPr>
-          <a:xfrm>
-            <a:off x="6426200" y="3289300"/>
-            <a:ext cx="2190750" cy="825500"/>
-          </a:xfrm>
-          <a:prstGeom prst="rect">
-            <a:avLst/>
-          </a:prstGeom>
-          <a:noFill/>
-        </p:spPr>
-        <p:txBody>
-          <a:bodyPr wrap="none" lIns="0" rIns="0" tIns="0" bIns="0" anchor="t">
-            <a:spAutoFit/>
-          </a:bodyPr>
-          <a:lstStyle/>
-          <a:p>
-            <a:pPr>
-              <a:lnSpc>
-                <a:spcPts val="2250"/>
-              </a:lnSpc>
-              <a:spcBef>
-                <a:spcPts val="0"/>
-              </a:spcBef>
-              <a:spcAft>
-                <a:spcPts val="0"/>
-              </a:spcAft>
-              <a:defRPr sz="1800" b="1">
+              <a:t>Payment proposal</a:t>
+            </a:r>
+          </a:p>
+        </p:txBody>
+      </p:sp>
+      <p:sp>
+        <p:nvSpPr>
+          <p:cNvPr id="21" name="TextBox 20"/>
+          <p:cNvSpPr txBox="1"/>
+          <p:nvPr/>
+        </p:nvSpPr>
+        <p:spPr>
+          <a:xfrm>
+            <a:off x="660400" y="3886200"/>
+            <a:ext cx="2095500" cy="596900"/>
+          </a:xfrm>
+          <a:prstGeom prst="rect">
+            <a:avLst/>
+          </a:prstGeom>
+          <a:noFill/>
+        </p:spPr>
+        <p:txBody>
+          <a:bodyPr wrap="none" lIns="0" rIns="0" tIns="0" bIns="0" anchor="t">
+            <a:spAutoFit/>
+          </a:bodyPr>
+          <a:lstStyle/>
+          <a:p>
+            <a:pPr>
+              <a:lnSpc>
+                <a:spcPts val="1380"/>
+              </a:lnSpc>
+              <a:spcBef>
+                <a:spcPts val="0"/>
+              </a:spcBef>
+              <a:spcAft>
+                <a:spcPts val="0"/>
+              </a:spcAft>
+              <a:defRPr sz="1200" b="0">
                 <a:solidFill>
                   <a:srgbClr val="163640"/>
                 </a:solidFill>
@@ -18952,44 +19109,21 @@
               </a:defRPr>
             </a:pPr>
             <a:r>
-              <a:t>Gate 3</a:t>
-            </a:r>
-          </a:p>
-        </p:txBody>
-      </p:sp>
-      <p:sp>
-        <p:nvSpPr>
-          <p:cNvPr id="19" name="TextBox 18"/>
-          <p:cNvSpPr txBox="1"/>
-          <p:nvPr/>
-        </p:nvSpPr>
-        <p:spPr>
-          <a:xfrm>
-            <a:off x="6426200" y="4140200"/>
-            <a:ext cx="2190750" cy="1257300"/>
-          </a:xfrm>
-          <a:prstGeom prst="rect">
-            <a:avLst/>
-          </a:prstGeom>
-          <a:noFill/>
-        </p:spPr>
-        <p:txBody>
-          <a:bodyPr wrap="none" lIns="0" rIns="0" tIns="0" bIns="0" anchor="t">
-            <a:spAutoFit/>
-          </a:bodyPr>
-          <a:lstStyle/>
-          <a:p>
-            <a:pPr>
-              <a:lnSpc>
-                <a:spcPts val="2125"/>
-              </a:lnSpc>
-              <a:spcBef>
-                <a:spcPts val="0"/>
-              </a:spcBef>
-              <a:spcAft>
-                <a:spcPts val="0"/>
-              </a:spcAft>
-              <a:defRPr sz="1700" b="0">
+              <a:t>Live: validated model call</a:t>
+            </a:r>
+          </a:p>
+          <a:p>
+            <a:pPr>
+              <a:lnSpc>
+                <a:spcPts val="1380"/>
+              </a:lnSpc>
+              <a:spcBef>
+                <a:spcPts val="0"/>
+              </a:spcBef>
+              <a:spcAft>
+                <a:spcPts val="0"/>
+              </a:spcAft>
+              <a:defRPr sz="1200" b="0">
                 <a:solidFill>
                   <a:srgbClr val="163640"/>
                 </a:solidFill>
@@ -18997,66 +19131,44 @@
               </a:defRPr>
             </a:pPr>
             <a:r>
-              <a:t>Downstream API</a:t>
-            </a:r>
-          </a:p>
-          <a:p>
-            <a:pPr>
-              <a:lnSpc>
-                <a:spcPts val="2125"/>
-              </a:lnSpc>
-              <a:spcBef>
-                <a:spcPts val="0"/>
-              </a:spcBef>
-              <a:spcAft>
-                <a:spcPts val="0"/>
-              </a:spcAft>
-              <a:defRPr sz="1700" b="0">
-                <a:solidFill>
-                  <a:srgbClr val="163640"/>
-                </a:solidFill>
-                <a:latin typeface="DejaVu Sans"/>
-              </a:defRPr>
-            </a:pPr>
-            <a:r>
-              <a:t>access</a:t>
-            </a:r>
-          </a:p>
-        </p:txBody>
-      </p:sp>
-      <p:sp>
-        <p:nvSpPr>
-          <p:cNvPr id="20" name="TextBox 19"/>
-          <p:cNvSpPr txBox="1"/>
-          <p:nvPr/>
-        </p:nvSpPr>
-        <p:spPr>
-          <a:xfrm>
-            <a:off x="8845550" y="3556000"/>
-            <a:ext cx="254000" cy="330200"/>
-          </a:xfrm>
-          <a:prstGeom prst="rect">
-            <a:avLst/>
-          </a:prstGeom>
-          <a:noFill/>
-        </p:spPr>
-        <p:txBody>
-          <a:bodyPr wrap="none" lIns="0" rIns="0" tIns="0" bIns="0" anchor="t">
-            <a:spAutoFit/>
-          </a:bodyPr>
-          <a:lstStyle/>
-          <a:p>
-            <a:pPr>
-              <a:lnSpc>
-                <a:spcPts val="2187"/>
-              </a:lnSpc>
-              <a:spcBef>
-                <a:spcPts val="0"/>
-              </a:spcBef>
-              <a:spcAft>
-                <a:spcPts val="0"/>
-              </a:spcAft>
-              <a:defRPr sz="1750" b="0">
+              <a:t>Replay: fixed request</a:t>
+            </a:r>
+          </a:p>
+        </p:txBody>
+      </p:sp>
+      <p:sp>
+        <p:nvSpPr>
+          <p:cNvPr id="22" name="TextBox 21"/>
+          <p:cNvSpPr txBox="1"/>
+          <p:nvPr/>
+        </p:nvSpPr>
+        <p:spPr>
+          <a:xfrm>
+            <a:off x="2971800" y="3746500"/>
+            <a:ext cx="381000" cy="355600"/>
+          </a:xfrm>
+          <a:prstGeom prst="rect">
+            <a:avLst/>
+          </a:prstGeom>
+          <a:noFill/>
+        </p:spPr>
+        <p:txBody>
+          <a:bodyPr wrap="none" lIns="0" rIns="0" tIns="0" bIns="0" anchor="t">
+            <a:spAutoFit/>
+          </a:bodyPr>
+          <a:lstStyle/>
+          <a:p>
+            <a:pPr>
+              <a:lnSpc>
+                <a:spcPts val="2375"/>
+              </a:lnSpc>
+              <a:spcBef>
+                <a:spcPts val="0"/>
+              </a:spcBef>
+              <a:spcAft>
+                <a:spcPts val="0"/>
+              </a:spcAft>
+              <a:defRPr sz="1900" b="0">
                 <a:solidFill>
                   <a:srgbClr val="007F79"/>
                 </a:solidFill>
@@ -19071,14 +19183,14 @@
       </p:sp>
       <p:sp>
         <p:nvSpPr>
-          <p:cNvPr id="21" name="Rounded Rectangle 20"/>
+          <p:cNvPr id="23" name="Rounded Rectangle 22"/>
           <p:cNvSpPr/>
           <p:nvPr/>
         </p:nvSpPr>
         <p:spPr>
           <a:xfrm>
-            <a:off x="9086850" y="2451100"/>
-            <a:ext cx="2571750" cy="3073400"/>
+            <a:off x="3390900" y="3429000"/>
+            <a:ext cx="2413000" cy="1104900"/>
           </a:xfrm>
           <a:prstGeom prst="roundRect">
             <a:avLst>
@@ -19116,37 +19228,37 @@
       </p:sp>
       <p:sp>
         <p:nvSpPr>
-          <p:cNvPr id="22" name="TextBox 21"/>
-          <p:cNvSpPr txBox="1"/>
-          <p:nvPr/>
-        </p:nvSpPr>
-        <p:spPr>
-          <a:xfrm>
-            <a:off x="9277350" y="2654300"/>
-            <a:ext cx="2190750" cy="482600"/>
-          </a:xfrm>
-          <a:prstGeom prst="rect">
-            <a:avLst/>
-          </a:prstGeom>
-          <a:noFill/>
-        </p:spPr>
-        <p:txBody>
-          <a:bodyPr wrap="none" lIns="0" rIns="0" tIns="0" bIns="0" anchor="t">
-            <a:spAutoFit/>
-          </a:bodyPr>
-          <a:lstStyle/>
-          <a:p>
-            <a:pPr>
-              <a:lnSpc>
-                <a:spcPts val="2750"/>
-              </a:lnSpc>
-              <a:spcBef>
-                <a:spcPts val="0"/>
-              </a:spcBef>
-              <a:spcAft>
-                <a:spcPts val="0"/>
-              </a:spcAft>
-              <a:defRPr sz="2200" b="1">
+          <p:cNvPr id="24" name="TextBox 23"/>
+          <p:cNvSpPr txBox="1"/>
+          <p:nvPr/>
+        </p:nvSpPr>
+        <p:spPr>
+          <a:xfrm>
+            <a:off x="3517900" y="3543300"/>
+            <a:ext cx="2159000" cy="317500"/>
+          </a:xfrm>
+          <a:prstGeom prst="rect">
+            <a:avLst/>
+          </a:prstGeom>
+          <a:noFill/>
+        </p:spPr>
+        <p:txBody>
+          <a:bodyPr wrap="none" lIns="0" rIns="0" tIns="0" bIns="0" anchor="t">
+            <a:spAutoFit/>
+          </a:bodyPr>
+          <a:lstStyle/>
+          <a:p>
+            <a:pPr>
+              <a:lnSpc>
+                <a:spcPts val="1687"/>
+              </a:lnSpc>
+              <a:spcBef>
+                <a:spcPts val="0"/>
+              </a:spcBef>
+              <a:spcAft>
+                <a:spcPts val="0"/>
+              </a:spcAft>
+              <a:defRPr sz="1350" b="1">
                 <a:solidFill>
                   <a:srgbClr val="007F79"/>
                 </a:solidFill>
@@ -19154,44 +19266,44 @@
               </a:defRPr>
             </a:pPr>
             <a:r>
-              <a:t>04</a:t>
-            </a:r>
-          </a:p>
-        </p:txBody>
-      </p:sp>
-      <p:sp>
-        <p:nvSpPr>
-          <p:cNvPr id="23" name="TextBox 22"/>
-          <p:cNvSpPr txBox="1"/>
-          <p:nvPr/>
-        </p:nvSpPr>
-        <p:spPr>
-          <a:xfrm>
-            <a:off x="9277350" y="3289300"/>
-            <a:ext cx="2190750" cy="825500"/>
-          </a:xfrm>
-          <a:prstGeom prst="rect">
-            <a:avLst/>
-          </a:prstGeom>
-          <a:noFill/>
-        </p:spPr>
-        <p:txBody>
-          <a:bodyPr wrap="none" lIns="0" rIns="0" tIns="0" bIns="0" anchor="t">
-            <a:spAutoFit/>
-          </a:bodyPr>
-          <a:lstStyle/>
-          <a:p>
-            <a:pPr>
-              <a:lnSpc>
-                <a:spcPts val="2250"/>
-              </a:lnSpc>
-              <a:spcBef>
-                <a:spcPts val="0"/>
-              </a:spcBef>
-              <a:spcAft>
-                <a:spcPts val="0"/>
-              </a:spcAft>
-              <a:defRPr sz="1800" b="1">
+              <a:t>Gate 2 / MCP adapter</a:t>
+            </a:r>
+          </a:p>
+        </p:txBody>
+      </p:sp>
+      <p:sp>
+        <p:nvSpPr>
+          <p:cNvPr id="25" name="TextBox 24"/>
+          <p:cNvSpPr txBox="1"/>
+          <p:nvPr/>
+        </p:nvSpPr>
+        <p:spPr>
+          <a:xfrm>
+            <a:off x="3517900" y="3886200"/>
+            <a:ext cx="2159000" cy="596900"/>
+          </a:xfrm>
+          <a:prstGeom prst="rect">
+            <a:avLst/>
+          </a:prstGeom>
+          <a:noFill/>
+        </p:spPr>
+        <p:txBody>
+          <a:bodyPr wrap="none" lIns="0" rIns="0" tIns="0" bIns="0" anchor="t">
+            <a:spAutoFit/>
+          </a:bodyPr>
+          <a:lstStyle/>
+          <a:p>
+            <a:pPr>
+              <a:lnSpc>
+                <a:spcPts val="1380"/>
+              </a:lnSpc>
+              <a:spcBef>
+                <a:spcPts val="0"/>
+              </a:spcBef>
+              <a:spcAft>
+                <a:spcPts val="0"/>
+              </a:spcAft>
+              <a:defRPr sz="1200" b="0">
                 <a:solidFill>
                   <a:srgbClr val="163640"/>
                 </a:solidFill>
@@ -19199,6 +19311,387 @@
               </a:defRPr>
             </a:pPr>
             <a:r>
+              <a:t>Signed identity +</a:t>
+            </a:r>
+          </a:p>
+          <a:p>
+            <a:pPr>
+              <a:lnSpc>
+                <a:spcPts val="1380"/>
+              </a:lnSpc>
+              <a:spcBef>
+                <a:spcPts val="0"/>
+              </a:spcBef>
+              <a:spcAft>
+                <a:spcPts val="0"/>
+              </a:spcAft>
+              <a:defRPr sz="1200" b="0">
+                <a:solidFill>
+                  <a:srgbClr val="163640"/>
+                </a:solidFill>
+                <a:latin typeface="DejaVu Sans"/>
+              </a:defRPr>
+            </a:pPr>
+            <a:r>
+              <a:t>arguments</a:t>
+            </a:r>
+          </a:p>
+          <a:p>
+            <a:pPr>
+              <a:lnSpc>
+                <a:spcPts val="1380"/>
+              </a:lnSpc>
+              <a:spcBef>
+                <a:spcPts val="0"/>
+              </a:spcBef>
+              <a:spcAft>
+                <a:spcPts val="0"/>
+              </a:spcAft>
+              <a:defRPr sz="1200" b="0">
+                <a:solidFill>
+                  <a:srgbClr val="163640"/>
+                </a:solidFill>
+                <a:latin typeface="DejaVu Sans"/>
+              </a:defRPr>
+            </a:pPr>
+            <a:r>
+              <a:t>OPA decision; fail closed</a:t>
+            </a:r>
+          </a:p>
+        </p:txBody>
+      </p:sp>
+      <p:sp>
+        <p:nvSpPr>
+          <p:cNvPr id="26" name="TextBox 25"/>
+          <p:cNvSpPr txBox="1"/>
+          <p:nvPr/>
+        </p:nvSpPr>
+        <p:spPr>
+          <a:xfrm>
+            <a:off x="5905500" y="3746500"/>
+            <a:ext cx="381000" cy="355600"/>
+          </a:xfrm>
+          <a:prstGeom prst="rect">
+            <a:avLst/>
+          </a:prstGeom>
+          <a:noFill/>
+        </p:spPr>
+        <p:txBody>
+          <a:bodyPr wrap="none" lIns="0" rIns="0" tIns="0" bIns="0" anchor="t">
+            <a:spAutoFit/>
+          </a:bodyPr>
+          <a:lstStyle/>
+          <a:p>
+            <a:pPr>
+              <a:lnSpc>
+                <a:spcPts val="2375"/>
+              </a:lnSpc>
+              <a:spcBef>
+                <a:spcPts val="0"/>
+              </a:spcBef>
+              <a:spcAft>
+                <a:spcPts val="0"/>
+              </a:spcAft>
+              <a:defRPr sz="1900" b="0">
+                <a:solidFill>
+                  <a:srgbClr val="007F79"/>
+                </a:solidFill>
+                <a:latin typeface="DejaVu Sans"/>
+              </a:defRPr>
+            </a:pPr>
+            <a:r>
+              <a:t>→</a:t>
+            </a:r>
+          </a:p>
+        </p:txBody>
+      </p:sp>
+      <p:sp>
+        <p:nvSpPr>
+          <p:cNvPr id="27" name="Rounded Rectangle 26"/>
+          <p:cNvSpPr/>
+          <p:nvPr/>
+        </p:nvSpPr>
+        <p:spPr>
+          <a:xfrm>
+            <a:off x="6337300" y="3429000"/>
+            <a:ext cx="2349500" cy="1104900"/>
+          </a:xfrm>
+          <a:prstGeom prst="roundRect">
+            <a:avLst>
+              <a:gd name="adj" fmla="val 6000"/>
+            </a:avLst>
+          </a:prstGeom>
+          <a:solidFill>
+            <a:srgbClr val="FFFFFF"/>
+          </a:solidFill>
+          <a:ln>
+            <a:noFill/>
+          </a:ln>
+        </p:spPr>
+        <p:style>
+          <a:lnRef idx="1">
+            <a:schemeClr val="accent1"/>
+          </a:lnRef>
+          <a:fillRef idx="3">
+            <a:schemeClr val="accent1"/>
+          </a:fillRef>
+          <a:effectRef idx="2">
+            <a:schemeClr val="accent1"/>
+          </a:effectRef>
+          <a:fontRef idx="minor">
+            <a:schemeClr val="lt1"/>
+          </a:fontRef>
+        </p:style>
+        <p:txBody>
+          <a:bodyPr rtlCol="0" anchor="ctr"/>
+          <a:lstStyle/>
+          <a:p>
+            <a:pPr algn="ctr"/>
+          </a:p>
+        </p:txBody>
+      </p:sp>
+      <p:sp>
+        <p:nvSpPr>
+          <p:cNvPr id="28" name="TextBox 27"/>
+          <p:cNvSpPr txBox="1"/>
+          <p:nvPr/>
+        </p:nvSpPr>
+        <p:spPr>
+          <a:xfrm>
+            <a:off x="6464300" y="3543300"/>
+            <a:ext cx="2095500" cy="317500"/>
+          </a:xfrm>
+          <a:prstGeom prst="rect">
+            <a:avLst/>
+          </a:prstGeom>
+          <a:noFill/>
+        </p:spPr>
+        <p:txBody>
+          <a:bodyPr wrap="none" lIns="0" rIns="0" tIns="0" bIns="0" anchor="t">
+            <a:spAutoFit/>
+          </a:bodyPr>
+          <a:lstStyle/>
+          <a:p>
+            <a:pPr>
+              <a:lnSpc>
+                <a:spcPts val="1687"/>
+              </a:lnSpc>
+              <a:spcBef>
+                <a:spcPts val="0"/>
+              </a:spcBef>
+              <a:spcAft>
+                <a:spcPts val="0"/>
+              </a:spcAft>
+              <a:defRPr sz="1350" b="1">
+                <a:solidFill>
+                  <a:srgbClr val="007F79"/>
+                </a:solidFill>
+                <a:latin typeface="DejaVu Sans"/>
+              </a:defRPr>
+            </a:pPr>
+            <a:r>
+              <a:t>Gate 3 / API gateway</a:t>
+            </a:r>
+          </a:p>
+        </p:txBody>
+      </p:sp>
+      <p:sp>
+        <p:nvSpPr>
+          <p:cNvPr id="29" name="TextBox 28"/>
+          <p:cNvSpPr txBox="1"/>
+          <p:nvPr/>
+        </p:nvSpPr>
+        <p:spPr>
+          <a:xfrm>
+            <a:off x="6464300" y="3886200"/>
+            <a:ext cx="2095500" cy="596900"/>
+          </a:xfrm>
+          <a:prstGeom prst="rect">
+            <a:avLst/>
+          </a:prstGeom>
+          <a:noFill/>
+        </p:spPr>
+        <p:txBody>
+          <a:bodyPr wrap="none" lIns="0" rIns="0" tIns="0" bIns="0" anchor="t">
+            <a:spAutoFit/>
+          </a:bodyPr>
+          <a:lstStyle/>
+          <a:p>
+            <a:pPr>
+              <a:lnSpc>
+                <a:spcPts val="1380"/>
+              </a:lnSpc>
+              <a:spcBef>
+                <a:spcPts val="0"/>
+              </a:spcBef>
+              <a:spcAft>
+                <a:spcPts val="0"/>
+              </a:spcAft>
+              <a:defRPr sz="1200" b="0">
+                <a:solidFill>
+                  <a:srgbClr val="163640"/>
+                </a:solidFill>
+                <a:latin typeface="DejaVu Sans"/>
+              </a:defRPr>
+            </a:pPr>
+            <a:r>
+              <a:t>API-key authentication</a:t>
+            </a:r>
+          </a:p>
+          <a:p>
+            <a:pPr>
+              <a:lnSpc>
+                <a:spcPts val="1380"/>
+              </a:lnSpc>
+              <a:spcBef>
+                <a:spcPts val="0"/>
+              </a:spcBef>
+              <a:spcAft>
+                <a:spcPts val="0"/>
+              </a:spcAft>
+              <a:defRPr sz="1200" b="0">
+                <a:solidFill>
+                  <a:srgbClr val="163640"/>
+                </a:solidFill>
+                <a:latin typeface="DejaVu Sans"/>
+              </a:defRPr>
+            </a:pPr>
+            <a:r>
+              <a:t>Forward authorized calls</a:t>
+            </a:r>
+          </a:p>
+        </p:txBody>
+      </p:sp>
+      <p:sp>
+        <p:nvSpPr>
+          <p:cNvPr id="30" name="TextBox 29"/>
+          <p:cNvSpPr txBox="1"/>
+          <p:nvPr/>
+        </p:nvSpPr>
+        <p:spPr>
+          <a:xfrm>
+            <a:off x="8788400" y="3746500"/>
+            <a:ext cx="381000" cy="355600"/>
+          </a:xfrm>
+          <a:prstGeom prst="rect">
+            <a:avLst/>
+          </a:prstGeom>
+          <a:noFill/>
+        </p:spPr>
+        <p:txBody>
+          <a:bodyPr wrap="none" lIns="0" rIns="0" tIns="0" bIns="0" anchor="t">
+            <a:spAutoFit/>
+          </a:bodyPr>
+          <a:lstStyle/>
+          <a:p>
+            <a:pPr>
+              <a:lnSpc>
+                <a:spcPts val="2375"/>
+              </a:lnSpc>
+              <a:spcBef>
+                <a:spcPts val="0"/>
+              </a:spcBef>
+              <a:spcAft>
+                <a:spcPts val="0"/>
+              </a:spcAft>
+              <a:defRPr sz="1900" b="0">
+                <a:solidFill>
+                  <a:srgbClr val="007F79"/>
+                </a:solidFill>
+                <a:latin typeface="DejaVu Sans"/>
+              </a:defRPr>
+            </a:pPr>
+            <a:r>
+              <a:t>→</a:t>
+            </a:r>
+          </a:p>
+        </p:txBody>
+      </p:sp>
+      <p:sp>
+        <p:nvSpPr>
+          <p:cNvPr id="31" name="Rounded Rectangle 30"/>
+          <p:cNvSpPr/>
+          <p:nvPr/>
+        </p:nvSpPr>
+        <p:spPr>
+          <a:xfrm>
+            <a:off x="9232900" y="3429000"/>
+            <a:ext cx="2413000" cy="1104900"/>
+          </a:xfrm>
+          <a:prstGeom prst="roundRect">
+            <a:avLst>
+              <a:gd name="adj" fmla="val 6000"/>
+            </a:avLst>
+          </a:prstGeom>
+          <a:solidFill>
+            <a:srgbClr val="FFFFFF"/>
+          </a:solidFill>
+          <a:ln>
+            <a:noFill/>
+          </a:ln>
+        </p:spPr>
+        <p:style>
+          <a:lnRef idx="1">
+            <a:schemeClr val="accent1"/>
+          </a:lnRef>
+          <a:fillRef idx="3">
+            <a:schemeClr val="accent1"/>
+          </a:fillRef>
+          <a:effectRef idx="2">
+            <a:schemeClr val="accent1"/>
+          </a:effectRef>
+          <a:fontRef idx="minor">
+            <a:schemeClr val="lt1"/>
+          </a:fontRef>
+        </p:style>
+        <p:txBody>
+          <a:bodyPr rtlCol="0" anchor="ctr"/>
+          <a:lstStyle/>
+          <a:p>
+            <a:pPr algn="ctr"/>
+          </a:p>
+        </p:txBody>
+      </p:sp>
+      <p:sp>
+        <p:nvSpPr>
+          <p:cNvPr id="32" name="TextBox 31"/>
+          <p:cNvSpPr txBox="1"/>
+          <p:nvPr/>
+        </p:nvSpPr>
+        <p:spPr>
+          <a:xfrm>
+            <a:off x="9359900" y="3543300"/>
+            <a:ext cx="2159000" cy="317500"/>
+          </a:xfrm>
+          <a:prstGeom prst="rect">
+            <a:avLst/>
+          </a:prstGeom>
+          <a:noFill/>
+        </p:spPr>
+        <p:txBody>
+          <a:bodyPr wrap="none" lIns="0" rIns="0" tIns="0" bIns="0" anchor="t">
+            <a:spAutoFit/>
+          </a:bodyPr>
+          <a:lstStyle/>
+          <a:p>
+            <a:pPr>
+              <a:lnSpc>
+                <a:spcPts val="1750"/>
+              </a:lnSpc>
+              <a:spcBef>
+                <a:spcPts val="0"/>
+              </a:spcBef>
+              <a:spcAft>
+                <a:spcPts val="0"/>
+              </a:spcAft>
+              <a:defRPr sz="1400" b="1">
+                <a:solidFill>
+                  <a:srgbClr val="007F79"/>
+                </a:solidFill>
+                <a:latin typeface="DejaVu Sans"/>
+              </a:defRPr>
+            </a:pPr>
+            <a:r>
               <a:t>Core Banking</a:t>
             </a:r>
           </a:p>
@@ -19206,37 +19699,37 @@
       </p:sp>
       <p:sp>
         <p:nvSpPr>
-          <p:cNvPr id="24" name="TextBox 23"/>
-          <p:cNvSpPr txBox="1"/>
-          <p:nvPr/>
-        </p:nvSpPr>
-        <p:spPr>
-          <a:xfrm>
-            <a:off x="9277350" y="4140200"/>
-            <a:ext cx="2190750" cy="1257300"/>
-          </a:xfrm>
-          <a:prstGeom prst="rect">
-            <a:avLst/>
-          </a:prstGeom>
-          <a:noFill/>
-        </p:spPr>
-        <p:txBody>
-          <a:bodyPr wrap="none" lIns="0" rIns="0" tIns="0" bIns="0" anchor="t">
-            <a:spAutoFit/>
-          </a:bodyPr>
-          <a:lstStyle/>
-          <a:p>
-            <a:pPr>
-              <a:lnSpc>
-                <a:spcPts val="2125"/>
-              </a:lnSpc>
-              <a:spcBef>
-                <a:spcPts val="0"/>
-              </a:spcBef>
-              <a:spcAft>
-                <a:spcPts val="0"/>
-              </a:spcAft>
-              <a:defRPr sz="1700" b="0">
+          <p:cNvPr id="33" name="TextBox 32"/>
+          <p:cNvSpPr txBox="1"/>
+          <p:nvPr/>
+        </p:nvSpPr>
+        <p:spPr>
+          <a:xfrm>
+            <a:off x="9359900" y="3886200"/>
+            <a:ext cx="2159000" cy="596900"/>
+          </a:xfrm>
+          <a:prstGeom prst="rect">
+            <a:avLst/>
+          </a:prstGeom>
+          <a:noFill/>
+        </p:spPr>
+        <p:txBody>
+          <a:bodyPr wrap="none" lIns="0" rIns="0" tIns="0" bIns="0" anchor="t">
+            <a:spAutoFit/>
+          </a:bodyPr>
+          <a:lstStyle/>
+          <a:p>
+            <a:pPr>
+              <a:lnSpc>
+                <a:spcPts val="1380"/>
+              </a:lnSpc>
+              <a:spcBef>
+                <a:spcPts val="0"/>
+              </a:spcBef>
+              <a:spcAft>
+                <a:spcPts val="0"/>
+              </a:spcAft>
+              <a:defRPr sz="1200" b="0">
                 <a:solidFill>
                   <a:srgbClr val="163640"/>
                 </a:solidFill>
@@ -19244,21 +19737,21 @@
               </a:defRPr>
             </a:pPr>
             <a:r>
-              <a:t>Approval + ledger</a:t>
-            </a:r>
-          </a:p>
-          <a:p>
-            <a:pPr>
-              <a:lnSpc>
-                <a:spcPts val="2125"/>
-              </a:lnSpc>
-              <a:spcBef>
-                <a:spcPts val="0"/>
-              </a:spcBef>
-              <a:spcAft>
-                <a:spcPts val="0"/>
-              </a:spcAft>
-              <a:defRPr sz="1700" b="0">
+              <a:t>JWT + business rules</a:t>
+            </a:r>
+          </a:p>
+          <a:p>
+            <a:pPr>
+              <a:lnSpc>
+                <a:spcPts val="1380"/>
+              </a:lnSpc>
+              <a:spcBef>
+                <a:spcPts val="0"/>
+              </a:spcBef>
+              <a:spcAft>
+                <a:spcPts val="0"/>
+              </a:spcAft>
+              <a:defRPr sz="1200" b="0">
                 <a:solidFill>
                   <a:srgbClr val="163640"/>
                 </a:solidFill>
@@ -19266,14 +19759,598 @@
               </a:defRPr>
             </a:pPr>
             <a:r>
-              <a:t>rules</a:t>
-            </a:r>
-          </a:p>
-        </p:txBody>
-      </p:sp>
-      <p:sp>
-        <p:nvSpPr>
-          <p:cNvPr id="25" name="Rounded Rectangle 24"/>
+              <a:t>Approvals and ledger</a:t>
+            </a:r>
+          </a:p>
+        </p:txBody>
+      </p:sp>
+      <p:sp>
+        <p:nvSpPr>
+          <p:cNvPr id="34" name="TextBox 33"/>
+          <p:cNvSpPr txBox="1"/>
+          <p:nvPr/>
+        </p:nvSpPr>
+        <p:spPr>
+          <a:xfrm>
+            <a:off x="4432300" y="4533900"/>
+            <a:ext cx="381000" cy="355600"/>
+          </a:xfrm>
+          <a:prstGeom prst="rect">
+            <a:avLst/>
+          </a:prstGeom>
+          <a:noFill/>
+        </p:spPr>
+        <p:txBody>
+          <a:bodyPr wrap="none" lIns="0" rIns="0" tIns="0" bIns="0" anchor="t">
+            <a:spAutoFit/>
+          </a:bodyPr>
+          <a:lstStyle/>
+          <a:p>
+            <a:pPr>
+              <a:lnSpc>
+                <a:spcPts val="2375"/>
+              </a:lnSpc>
+              <a:spcBef>
+                <a:spcPts val="0"/>
+              </a:spcBef>
+              <a:spcAft>
+                <a:spcPts val="0"/>
+              </a:spcAft>
+              <a:defRPr sz="1900" b="0">
+                <a:solidFill>
+                  <a:srgbClr val="007F79"/>
+                </a:solidFill>
+                <a:latin typeface="DejaVu Sans"/>
+              </a:defRPr>
+            </a:pPr>
+            <a:r>
+              <a:t>↕</a:t>
+            </a:r>
+          </a:p>
+        </p:txBody>
+      </p:sp>
+      <p:sp>
+        <p:nvSpPr>
+          <p:cNvPr id="35" name="Rounded Rectangle 34"/>
+          <p:cNvSpPr/>
+          <p:nvPr/>
+        </p:nvSpPr>
+        <p:spPr>
+          <a:xfrm>
+            <a:off x="3390900" y="4914900"/>
+            <a:ext cx="2413000" cy="736600"/>
+          </a:xfrm>
+          <a:prstGeom prst="roundRect">
+            <a:avLst>
+              <a:gd name="adj" fmla="val 6000"/>
+            </a:avLst>
+          </a:prstGeom>
+          <a:solidFill>
+            <a:srgbClr val="FFFFFF"/>
+          </a:solidFill>
+          <a:ln>
+            <a:noFill/>
+          </a:ln>
+        </p:spPr>
+        <p:style>
+          <a:lnRef idx="1">
+            <a:schemeClr val="accent1"/>
+          </a:lnRef>
+          <a:fillRef idx="3">
+            <a:schemeClr val="accent1"/>
+          </a:fillRef>
+          <a:effectRef idx="2">
+            <a:schemeClr val="accent1"/>
+          </a:effectRef>
+          <a:fontRef idx="minor">
+            <a:schemeClr val="lt1"/>
+          </a:fontRef>
+        </p:style>
+        <p:txBody>
+          <a:bodyPr rtlCol="0" anchor="ctr"/>
+          <a:lstStyle/>
+          <a:p>
+            <a:pPr algn="ctr"/>
+          </a:p>
+        </p:txBody>
+      </p:sp>
+      <p:sp>
+        <p:nvSpPr>
+          <p:cNvPr id="36" name="TextBox 35"/>
+          <p:cNvSpPr txBox="1"/>
+          <p:nvPr/>
+        </p:nvSpPr>
+        <p:spPr>
+          <a:xfrm>
+            <a:off x="3517900" y="5029200"/>
+            <a:ext cx="2159000" cy="317500"/>
+          </a:xfrm>
+          <a:prstGeom prst="rect">
+            <a:avLst/>
+          </a:prstGeom>
+          <a:noFill/>
+        </p:spPr>
+        <p:txBody>
+          <a:bodyPr wrap="none" lIns="0" rIns="0" tIns="0" bIns="0" anchor="t">
+            <a:spAutoFit/>
+          </a:bodyPr>
+          <a:lstStyle/>
+          <a:p>
+            <a:pPr>
+              <a:lnSpc>
+                <a:spcPts val="1750"/>
+              </a:lnSpc>
+              <a:spcBef>
+                <a:spcPts val="0"/>
+              </a:spcBef>
+              <a:spcAft>
+                <a:spcPts val="0"/>
+              </a:spcAft>
+              <a:defRPr sz="1400" b="1">
+                <a:solidFill>
+                  <a:srgbClr val="007F79"/>
+                </a:solidFill>
+                <a:latin typeface="DejaVu Sans"/>
+              </a:defRPr>
+            </a:pPr>
+            <a:r>
+              <a:t>OPA</a:t>
+            </a:r>
+          </a:p>
+        </p:txBody>
+      </p:sp>
+      <p:sp>
+        <p:nvSpPr>
+          <p:cNvPr id="37" name="TextBox 36"/>
+          <p:cNvSpPr txBox="1"/>
+          <p:nvPr/>
+        </p:nvSpPr>
+        <p:spPr>
+          <a:xfrm>
+            <a:off x="3517900" y="5372100"/>
+            <a:ext cx="2159000" cy="228600"/>
+          </a:xfrm>
+          <a:prstGeom prst="rect">
+            <a:avLst/>
+          </a:prstGeom>
+          <a:noFill/>
+        </p:spPr>
+        <p:txBody>
+          <a:bodyPr wrap="none" lIns="0" rIns="0" tIns="0" bIns="0" anchor="t">
+            <a:spAutoFit/>
+          </a:bodyPr>
+          <a:lstStyle/>
+          <a:p>
+            <a:pPr>
+              <a:lnSpc>
+                <a:spcPts val="1380"/>
+              </a:lnSpc>
+              <a:spcBef>
+                <a:spcPts val="0"/>
+              </a:spcBef>
+              <a:spcAft>
+                <a:spcPts val="0"/>
+              </a:spcAft>
+              <a:defRPr sz="1200" b="0">
+                <a:solidFill>
+                  <a:srgbClr val="163640"/>
+                </a:solidFill>
+                <a:latin typeface="DejaVu Sans"/>
+              </a:defRPr>
+            </a:pPr>
+            <a:r>
+              <a:t>Role / amount / beneficiary</a:t>
+            </a:r>
+          </a:p>
+        </p:txBody>
+      </p:sp>
+      <p:sp>
+        <p:nvSpPr>
+          <p:cNvPr id="38" name="TextBox 37"/>
+          <p:cNvSpPr txBox="1"/>
+          <p:nvPr/>
+        </p:nvSpPr>
+        <p:spPr>
+          <a:xfrm>
+            <a:off x="10261600" y="4533900"/>
+            <a:ext cx="381000" cy="355600"/>
+          </a:xfrm>
+          <a:prstGeom prst="rect">
+            <a:avLst/>
+          </a:prstGeom>
+          <a:noFill/>
+        </p:spPr>
+        <p:txBody>
+          <a:bodyPr wrap="none" lIns="0" rIns="0" tIns="0" bIns="0" anchor="t">
+            <a:spAutoFit/>
+          </a:bodyPr>
+          <a:lstStyle/>
+          <a:p>
+            <a:pPr>
+              <a:lnSpc>
+                <a:spcPts val="2375"/>
+              </a:lnSpc>
+              <a:spcBef>
+                <a:spcPts val="0"/>
+              </a:spcBef>
+              <a:spcAft>
+                <a:spcPts val="0"/>
+              </a:spcAft>
+              <a:defRPr sz="1900" b="0">
+                <a:solidFill>
+                  <a:srgbClr val="007F79"/>
+                </a:solidFill>
+                <a:latin typeface="DejaVu Sans"/>
+              </a:defRPr>
+            </a:pPr>
+            <a:r>
+              <a:t>↕</a:t>
+            </a:r>
+          </a:p>
+        </p:txBody>
+      </p:sp>
+      <p:sp>
+        <p:nvSpPr>
+          <p:cNvPr id="39" name="Rounded Rectangle 38"/>
+          <p:cNvSpPr/>
+          <p:nvPr/>
+        </p:nvSpPr>
+        <p:spPr>
+          <a:xfrm>
+            <a:off x="9232900" y="4914900"/>
+            <a:ext cx="2413000" cy="736600"/>
+          </a:xfrm>
+          <a:prstGeom prst="roundRect">
+            <a:avLst>
+              <a:gd name="adj" fmla="val 6000"/>
+            </a:avLst>
+          </a:prstGeom>
+          <a:solidFill>
+            <a:srgbClr val="FFFFFF"/>
+          </a:solidFill>
+          <a:ln>
+            <a:noFill/>
+          </a:ln>
+        </p:spPr>
+        <p:style>
+          <a:lnRef idx="1">
+            <a:schemeClr val="accent1"/>
+          </a:lnRef>
+          <a:fillRef idx="3">
+            <a:schemeClr val="accent1"/>
+          </a:fillRef>
+          <a:effectRef idx="2">
+            <a:schemeClr val="accent1"/>
+          </a:effectRef>
+          <a:fontRef idx="minor">
+            <a:schemeClr val="lt1"/>
+          </a:fontRef>
+        </p:style>
+        <p:txBody>
+          <a:bodyPr rtlCol="0" anchor="ctr"/>
+          <a:lstStyle/>
+          <a:p>
+            <a:pPr algn="ctr"/>
+          </a:p>
+        </p:txBody>
+      </p:sp>
+      <p:sp>
+        <p:nvSpPr>
+          <p:cNvPr id="40" name="TextBox 39"/>
+          <p:cNvSpPr txBox="1"/>
+          <p:nvPr/>
+        </p:nvSpPr>
+        <p:spPr>
+          <a:xfrm>
+            <a:off x="9359900" y="5029200"/>
+            <a:ext cx="2159000" cy="317500"/>
+          </a:xfrm>
+          <a:prstGeom prst="rect">
+            <a:avLst/>
+          </a:prstGeom>
+          <a:noFill/>
+        </p:spPr>
+        <p:txBody>
+          <a:bodyPr wrap="none" lIns="0" rIns="0" tIns="0" bIns="0" anchor="t">
+            <a:spAutoFit/>
+          </a:bodyPr>
+          <a:lstStyle/>
+          <a:p>
+            <a:pPr>
+              <a:lnSpc>
+                <a:spcPts val="1750"/>
+              </a:lnSpc>
+              <a:spcBef>
+                <a:spcPts val="0"/>
+              </a:spcBef>
+              <a:spcAft>
+                <a:spcPts val="0"/>
+              </a:spcAft>
+              <a:defRPr sz="1400" b="1">
+                <a:solidFill>
+                  <a:srgbClr val="007F79"/>
+                </a:solidFill>
+                <a:latin typeface="DejaVu Sans"/>
+              </a:defRPr>
+            </a:pPr>
+            <a:r>
+              <a:t>PostgreSQL</a:t>
+            </a:r>
+          </a:p>
+        </p:txBody>
+      </p:sp>
+      <p:sp>
+        <p:nvSpPr>
+          <p:cNvPr id="41" name="TextBox 40"/>
+          <p:cNvSpPr txBox="1"/>
+          <p:nvPr/>
+        </p:nvSpPr>
+        <p:spPr>
+          <a:xfrm>
+            <a:off x="9359900" y="5372100"/>
+            <a:ext cx="2159000" cy="228600"/>
+          </a:xfrm>
+          <a:prstGeom prst="rect">
+            <a:avLst/>
+          </a:prstGeom>
+          <a:noFill/>
+        </p:spPr>
+        <p:txBody>
+          <a:bodyPr wrap="none" lIns="0" rIns="0" tIns="0" bIns="0" anchor="t">
+            <a:spAutoFit/>
+          </a:bodyPr>
+          <a:lstStyle/>
+          <a:p>
+            <a:pPr>
+              <a:lnSpc>
+                <a:spcPts val="1380"/>
+              </a:lnSpc>
+              <a:spcBef>
+                <a:spcPts val="0"/>
+              </a:spcBef>
+              <a:spcAft>
+                <a:spcPts val="0"/>
+              </a:spcAft>
+              <a:defRPr sz="1200" b="0">
+                <a:solidFill>
+                  <a:srgbClr val="163640"/>
+                </a:solidFill>
+                <a:latin typeface="DejaVu Sans"/>
+              </a:defRPr>
+            </a:pPr>
+            <a:r>
+              <a:t>Banking records</a:t>
+            </a:r>
+          </a:p>
+        </p:txBody>
+      </p:sp>
+      <p:sp>
+        <p:nvSpPr>
+          <p:cNvPr id="42" name="Rounded Rectangle 41"/>
+          <p:cNvSpPr/>
+          <p:nvPr/>
+        </p:nvSpPr>
+        <p:spPr>
+          <a:xfrm>
+            <a:off x="6337300" y="4914900"/>
+            <a:ext cx="2349500" cy="736600"/>
+          </a:xfrm>
+          <a:prstGeom prst="roundRect">
+            <a:avLst>
+              <a:gd name="adj" fmla="val 6000"/>
+            </a:avLst>
+          </a:prstGeom>
+          <a:solidFill>
+            <a:srgbClr val="FFFFFF"/>
+          </a:solidFill>
+          <a:ln>
+            <a:noFill/>
+          </a:ln>
+        </p:spPr>
+        <p:style>
+          <a:lnRef idx="1">
+            <a:schemeClr val="accent1"/>
+          </a:lnRef>
+          <a:fillRef idx="3">
+            <a:schemeClr val="accent1"/>
+          </a:fillRef>
+          <a:effectRef idx="2">
+            <a:schemeClr val="accent1"/>
+          </a:effectRef>
+          <a:fontRef idx="minor">
+            <a:schemeClr val="lt1"/>
+          </a:fontRef>
+        </p:style>
+        <p:txBody>
+          <a:bodyPr rtlCol="0" anchor="ctr"/>
+          <a:lstStyle/>
+          <a:p>
+            <a:pPr algn="ctr"/>
+          </a:p>
+        </p:txBody>
+      </p:sp>
+      <p:sp>
+        <p:nvSpPr>
+          <p:cNvPr id="43" name="TextBox 42"/>
+          <p:cNvSpPr txBox="1"/>
+          <p:nvPr/>
+        </p:nvSpPr>
+        <p:spPr>
+          <a:xfrm>
+            <a:off x="6464300" y="5029200"/>
+            <a:ext cx="2095500" cy="317500"/>
+          </a:xfrm>
+          <a:prstGeom prst="rect">
+            <a:avLst/>
+          </a:prstGeom>
+          <a:noFill/>
+        </p:spPr>
+        <p:txBody>
+          <a:bodyPr wrap="none" lIns="0" rIns="0" tIns="0" bIns="0" anchor="t">
+            <a:spAutoFit/>
+          </a:bodyPr>
+          <a:lstStyle/>
+          <a:p>
+            <a:pPr>
+              <a:lnSpc>
+                <a:spcPts val="1750"/>
+              </a:lnSpc>
+              <a:spcBef>
+                <a:spcPts val="0"/>
+              </a:spcBef>
+              <a:spcAft>
+                <a:spcPts val="0"/>
+              </a:spcAft>
+              <a:defRPr sz="1400" b="1">
+                <a:solidFill>
+                  <a:srgbClr val="007F79"/>
+                </a:solidFill>
+                <a:latin typeface="DejaVu Sans"/>
+              </a:defRPr>
+            </a:pPr>
+            <a:r>
+              <a:t>Jaeger</a:t>
+            </a:r>
+          </a:p>
+        </p:txBody>
+      </p:sp>
+      <p:sp>
+        <p:nvSpPr>
+          <p:cNvPr id="44" name="TextBox 43"/>
+          <p:cNvSpPr txBox="1"/>
+          <p:nvPr/>
+        </p:nvSpPr>
+        <p:spPr>
+          <a:xfrm>
+            <a:off x="6464300" y="5372100"/>
+            <a:ext cx="2095500" cy="228600"/>
+          </a:xfrm>
+          <a:prstGeom prst="rect">
+            <a:avLst/>
+          </a:prstGeom>
+          <a:noFill/>
+        </p:spPr>
+        <p:txBody>
+          <a:bodyPr wrap="none" lIns="0" rIns="0" tIns="0" bIns="0" anchor="t">
+            <a:spAutoFit/>
+          </a:bodyPr>
+          <a:lstStyle/>
+          <a:p>
+            <a:pPr>
+              <a:lnSpc>
+                <a:spcPts val="1322"/>
+              </a:lnSpc>
+              <a:spcBef>
+                <a:spcPts val="0"/>
+              </a:spcBef>
+              <a:spcAft>
+                <a:spcPts val="0"/>
+              </a:spcAft>
+              <a:defRPr sz="1150" b="0">
+                <a:solidFill>
+                  <a:srgbClr val="163640"/>
+                </a:solidFill>
+                <a:latin typeface="DejaVu Sans"/>
+              </a:defRPr>
+            </a:pPr>
+            <a:r>
+              <a:t>Exported distributed traces</a:t>
+            </a:r>
+          </a:p>
+        </p:txBody>
+      </p:sp>
+      <p:sp>
+        <p:nvSpPr>
+          <p:cNvPr id="45" name="TextBox 44"/>
+          <p:cNvSpPr txBox="1"/>
+          <p:nvPr/>
+        </p:nvSpPr>
+        <p:spPr>
+          <a:xfrm>
+            <a:off x="533400" y="4851400"/>
+            <a:ext cx="2603500" cy="825500"/>
+          </a:xfrm>
+          <a:prstGeom prst="rect">
+            <a:avLst/>
+          </a:prstGeom>
+          <a:noFill/>
+        </p:spPr>
+        <p:txBody>
+          <a:bodyPr wrap="none" lIns="0" rIns="0" tIns="0" bIns="0" anchor="t">
+            <a:spAutoFit/>
+          </a:bodyPr>
+          <a:lstStyle/>
+          <a:p>
+            <a:pPr>
+              <a:lnSpc>
+                <a:spcPts val="1439"/>
+              </a:lnSpc>
+              <a:spcBef>
+                <a:spcPts val="0"/>
+              </a:spcBef>
+              <a:spcAft>
+                <a:spcPts val="0"/>
+              </a:spcAft>
+              <a:defRPr sz="1200" b="0">
+                <a:solidFill>
+                  <a:srgbClr val="536B73"/>
+                </a:solidFill>
+                <a:latin typeface="DejaVu Sans"/>
+              </a:defRPr>
+            </a:pPr>
+            <a:r>
+              <a:t>APISIX hosts Gates 1–3.</a:t>
+            </a:r>
+          </a:p>
+          <a:p>
+            <a:pPr>
+              <a:lnSpc>
+                <a:spcPts val="1439"/>
+              </a:lnSpc>
+              <a:spcBef>
+                <a:spcPts val="0"/>
+              </a:spcBef>
+              <a:spcAft>
+                <a:spcPts val="0"/>
+              </a:spcAft>
+              <a:defRPr sz="1200" b="0">
+                <a:solidFill>
+                  <a:srgbClr val="536B73"/>
+                </a:solidFill>
+                <a:latin typeface="DejaVu Sans"/>
+              </a:defRPr>
+            </a:pPr>
+            <a:r>
+              <a:t>Denied payments stop at Gate 2.</a:t>
+            </a:r>
+          </a:p>
+          <a:p>
+            <a:pPr>
+              <a:lnSpc>
+                <a:spcPts val="1439"/>
+              </a:lnSpc>
+              <a:spcBef>
+                <a:spcPts val="0"/>
+              </a:spcBef>
+              <a:spcAft>
+                <a:spcPts val="0"/>
+              </a:spcAft>
+              <a:defRPr sz="1200" b="0">
+                <a:solidFill>
+                  <a:srgbClr val="536B73"/>
+                </a:solidFill>
+                <a:latin typeface="DejaVu Sans"/>
+              </a:defRPr>
+            </a:pPr>
+            <a:r>
+              <a:t>Pending approval: no debit.</a:t>
+            </a:r>
+          </a:p>
+        </p:txBody>
+      </p:sp>
+      <p:sp>
+        <p:nvSpPr>
+          <p:cNvPr id="46" name="Rounded Rectangle 45"/>
           <p:cNvSpPr/>
           <p:nvPr/>
         </p:nvSpPr>
@@ -19318,7 +20395,7 @@
       </p:sp>
       <p:sp>
         <p:nvSpPr>
-          <p:cNvPr id="26" name="TextBox 25"/>
+          <p:cNvPr id="47" name="TextBox 46"/>
           <p:cNvSpPr txBox="1"/>
           <p:nvPr/>
         </p:nvSpPr>
@@ -19356,14 +20433,14 @@
               </a:defRPr>
             </a:pPr>
             <a:r>
-              <a:t>A decision is evidence only for the boundary that actually evaluated it.</a:t>
-            </a:r>
-          </a:p>
-        </p:txBody>
-      </p:sp>
-      <p:sp>
-        <p:nvSpPr>
-          <p:cNvPr id="27" name="TextBox 26"/>
+              <a:t>Replay skips Gate 1. Gate 2 checks authority before payment execution.</a:t>
+            </a:r>
+          </a:p>
+        </p:txBody>
+      </p:sp>
+      <p:sp>
+        <p:nvSpPr>
+          <p:cNvPr id="48" name="TextBox 47"/>
           <p:cNvSpPr txBox="1"/>
           <p:nvPr/>
         </p:nvSpPr>
@@ -19408,7 +20485,7 @@
       </p:sp>
       <p:sp>
         <p:nvSpPr>
-          <p:cNvPr id="28" name="TextBox 27"/>
+          <p:cNvPr id="49" name="TextBox 48"/>
           <p:cNvSpPr txBox="1"/>
           <p:nvPr/>
         </p:nvSpPr>

</xml_diff>